<commit_message>
docs: klantdeck aangescherpt (slide 3: 'vier soorten klanten' + één as sollicitant/klant; slide 4: 'één regel code' + privacyregel EU/geen persoonsprofielen) + draaiboek: deck is achtervang, geen opening
</commit_message>
<xml_diff>
--- a/docs/mister-chameleon-klant.pptx
+++ b/docs/mister-chameleon-klant.pptx
@@ -2169,7 +2169,7 @@
                 <a:ea typeface="Cambria" pitchFamily="34" charset="-122"/>
                 <a:cs typeface="Cambria" pitchFamily="34" charset="-120"/>
               </a:rPr>
-              <a:t>“Meerdere doelgroepen, en één website.”</a:t>
+              <a:t>“Vier soorten klanten, en één website.”</a:t>
             </a:r>
             <a:endParaRPr lang="en-US" sz="3800" dirty="0"/>
           </a:p>
@@ -2225,12 +2225,12 @@
         </p:nvSpPr>
         <p:spPr>
           <a:xfrm>
-            <a:off x="822960" y="3794760"/>
-            <a:ext cx="2286000" cy="914400"/>
+            <a:off x="1188720" y="3749040"/>
+            <a:ext cx="3566160" cy="960120"/>
           </a:xfrm>
           <a:prstGeom prst="roundRect">
             <a:avLst>
-              <a:gd name="adj" fmla="val 9000"/>
+              <a:gd name="adj" fmla="val 8571"/>
             </a:avLst>
           </a:prstGeom>
           <a:solidFill>
@@ -2254,8 +2254,8 @@
         </p:nvSpPr>
         <p:spPr>
           <a:xfrm>
-            <a:off x="822960" y="3794760"/>
-            <a:ext cx="2286000" cy="914400"/>
+            <a:off x="1188720" y="3749040"/>
+            <a:ext cx="3566160" cy="960120"/>
           </a:xfrm>
           <a:prstGeom prst="rect">
             <a:avLst/>
@@ -2271,7 +2271,7 @@
               <a:buNone/>
             </a:pPr>
             <a:r>
-              <a:rPr lang="en-US" sz="1500" b="1" dirty="0">
+              <a:rPr lang="en-US" sz="1800" b="1" dirty="0">
                 <a:solidFill>
                   <a:srgbClr val="FFFFFF"/>
                 </a:solidFill>
@@ -2281,24 +2281,63 @@
               </a:rPr>
               <a:t>Sollicitant</a:t>
             </a:r>
-            <a:endParaRPr lang="en-US" sz="1500" dirty="0"/>
-          </a:p>
-        </p:txBody>
-      </p:sp>
-      <p:sp>
-        <p:nvSpPr>
-          <p:cNvPr id="7" name="Shape 5"/>
-          <p:cNvSpPr/>
-          <p:nvPr/>
-        </p:nvSpPr>
-        <p:spPr>
-          <a:xfrm>
-            <a:off x="3337560" y="3794760"/>
-            <a:ext cx="2286000" cy="914400"/>
+            <a:endParaRPr lang="en-US" sz="1800" dirty="0"/>
+          </a:p>
+        </p:txBody>
+      </p:sp>
+      <p:sp>
+        <p:nvSpPr>
+          <p:cNvPr id="7" name="Text 5"/>
+          <p:cNvSpPr/>
+          <p:nvPr/>
+        </p:nvSpPr>
+        <p:spPr>
+          <a:xfrm>
+            <a:off x="4892040" y="3749040"/>
+            <a:ext cx="2377440" cy="960120"/>
+          </a:xfrm>
+          <a:prstGeom prst="rect">
+            <a:avLst/>
+          </a:prstGeom>
+          <a:noFill/>
+          <a:ln/>
+        </p:spPr>
+        <p:txBody>
+          <a:bodyPr wrap="square" lIns="0" tIns="0" rIns="0" bIns="0" rtlCol="0" anchor="ctr"/>
+          <a:lstStyle/>
+          <a:p>
+            <a:pPr algn="ctr" indent="0" marL="0">
+              <a:buNone/>
+            </a:pPr>
+            <a:r>
+              <a:rPr lang="en-US" sz="1400" i="1" dirty="0">
+                <a:solidFill>
+                  <a:srgbClr val="CFE8E6"/>
+                </a:solidFill>
+                <a:latin typeface="Calibri" pitchFamily="34" charset="0"/>
+                <a:ea typeface="Calibri" pitchFamily="34" charset="-122"/>
+                <a:cs typeface="Calibri" pitchFamily="34" charset="-120"/>
+              </a:rPr>
+              <a:t>zelfde pagina</a:t>
+            </a:r>
+            <a:endParaRPr lang="en-US" sz="1400" dirty="0"/>
+          </a:p>
+        </p:txBody>
+      </p:sp>
+      <p:sp>
+        <p:nvSpPr>
+          <p:cNvPr id="8" name="Shape 6"/>
+          <p:cNvSpPr/>
+          <p:nvPr/>
+        </p:nvSpPr>
+        <p:spPr>
+          <a:xfrm>
+            <a:off x="7406640" y="3749040"/>
+            <a:ext cx="3566160" cy="960120"/>
           </a:xfrm>
           <a:prstGeom prst="roundRect">
             <a:avLst>
-              <a:gd name="adj" fmla="val 9000"/>
+              <a:gd name="adj" fmla="val 8571"/>
             </a:avLst>
           </a:prstGeom>
           <a:solidFill>
@@ -2316,14 +2355,14 @@
       </p:sp>
       <p:sp>
         <p:nvSpPr>
-          <p:cNvPr id="8" name="Text 6"/>
-          <p:cNvSpPr/>
-          <p:nvPr/>
-        </p:nvSpPr>
-        <p:spPr>
-          <a:xfrm>
-            <a:off x="3337560" y="3794760"/>
-            <a:ext cx="2286000" cy="914400"/>
+          <p:cNvPr id="9" name="Text 7"/>
+          <p:cNvSpPr/>
+          <p:nvPr/>
+        </p:nvSpPr>
+        <p:spPr>
+          <a:xfrm>
+            <a:off x="7406640" y="3749040"/>
+            <a:ext cx="3566160" cy="960120"/>
           </a:xfrm>
           <a:prstGeom prst="rect">
             <a:avLst/>
@@ -2339,7 +2378,7 @@
               <a:buNone/>
             </a:pPr>
             <a:r>
-              <a:rPr lang="en-US" sz="1500" b="1" dirty="0">
+              <a:rPr lang="en-US" sz="1800" b="1" dirty="0">
                 <a:solidFill>
                   <a:srgbClr val="FFFFFF"/>
                 </a:solidFill>
@@ -2349,38 +2388,9 @@
               </a:rPr>
               <a:t>Klant</a:t>
             </a:r>
-            <a:endParaRPr lang="en-US" sz="1500" dirty="0"/>
-          </a:p>
-        </p:txBody>
-      </p:sp>
-      <p:sp>
-        <p:nvSpPr>
-          <p:cNvPr id="9" name="Shape 7"/>
-          <p:cNvSpPr/>
-          <p:nvPr/>
-        </p:nvSpPr>
-        <p:spPr>
-          <a:xfrm>
-            <a:off x="5852160" y="3794760"/>
-            <a:ext cx="2286000" cy="914400"/>
-          </a:xfrm>
-          <a:prstGeom prst="roundRect">
-            <a:avLst>
-              <a:gd name="adj" fmla="val 9000"/>
-            </a:avLst>
-          </a:prstGeom>
-          <a:solidFill>
-            <a:srgbClr val="12414E"/>
-          </a:solidFill>
-          <a:ln/>
-          <a:effectLst>
-            <a:outerShdw sx="100000" sy="100000" kx="0" ky="0" algn="bl" rotWithShape="0" blurRad="76200" dist="25400" dir="5400000">
-              <a:srgbClr val="9FB6B6">
-                <a:alpha val="28000"/>
-              </a:srgbClr>
-            </a:outerShdw>
-          </a:effectLst>
-        </p:spPr>
+            <a:endParaRPr lang="en-US" sz="1800" dirty="0"/>
+          </a:p>
+        </p:txBody>
       </p:sp>
       <p:sp>
         <p:nvSpPr>
@@ -2390,114 +2400,7 @@
         </p:nvSpPr>
         <p:spPr>
           <a:xfrm>
-            <a:off x="5852160" y="3794760"/>
-            <a:ext cx="2286000" cy="914400"/>
-          </a:xfrm>
-          <a:prstGeom prst="rect">
-            <a:avLst/>
-          </a:prstGeom>
-          <a:noFill/>
-          <a:ln/>
-        </p:spPr>
-        <p:txBody>
-          <a:bodyPr wrap="square" lIns="0" tIns="0" rIns="0" bIns="0" rtlCol="0" anchor="ctr"/>
-          <a:lstStyle/>
-          <a:p>
-            <a:pPr algn="ctr" indent="0" marL="0">
-              <a:buNone/>
-            </a:pPr>
-            <a:r>
-              <a:rPr lang="en-US" sz="1500" b="1" dirty="0">
-                <a:solidFill>
-                  <a:srgbClr val="FFFFFF"/>
-                </a:solidFill>
-                <a:latin typeface="Calibri" pitchFamily="34" charset="0"/>
-                <a:ea typeface="Calibri" pitchFamily="34" charset="-122"/>
-                <a:cs typeface="Calibri" pitchFamily="34" charset="-120"/>
-              </a:rPr>
-              <a:t>Nieuw</a:t>
-            </a:r>
-            <a:endParaRPr lang="en-US" sz="1500" dirty="0"/>
-          </a:p>
-        </p:txBody>
-      </p:sp>
-      <p:sp>
-        <p:nvSpPr>
-          <p:cNvPr id="11" name="Shape 9"/>
-          <p:cNvSpPr/>
-          <p:nvPr/>
-        </p:nvSpPr>
-        <p:spPr>
-          <a:xfrm>
-            <a:off x="8366760" y="3794760"/>
-            <a:ext cx="2286000" cy="914400"/>
-          </a:xfrm>
-          <a:prstGeom prst="roundRect">
-            <a:avLst>
-              <a:gd name="adj" fmla="val 9000"/>
-            </a:avLst>
-          </a:prstGeom>
-          <a:solidFill>
-            <a:srgbClr val="12414E"/>
-          </a:solidFill>
-          <a:ln/>
-          <a:effectLst>
-            <a:outerShdw sx="100000" sy="100000" kx="0" ky="0" algn="bl" rotWithShape="0" blurRad="76200" dist="25400" dir="5400000">
-              <a:srgbClr val="9FB6B6">
-                <a:alpha val="28000"/>
-              </a:srgbClr>
-            </a:outerShdw>
-          </a:effectLst>
-        </p:spPr>
-      </p:sp>
-      <p:sp>
-        <p:nvSpPr>
-          <p:cNvPr id="12" name="Text 10"/>
-          <p:cNvSpPr/>
-          <p:nvPr/>
-        </p:nvSpPr>
-        <p:spPr>
-          <a:xfrm>
-            <a:off x="8366760" y="3794760"/>
-            <a:ext cx="2286000" cy="914400"/>
-          </a:xfrm>
-          <a:prstGeom prst="rect">
-            <a:avLst/>
-          </a:prstGeom>
-          <a:noFill/>
-          <a:ln/>
-        </p:spPr>
-        <p:txBody>
-          <a:bodyPr wrap="square" lIns="0" tIns="0" rIns="0" bIns="0" rtlCol="0" anchor="ctr"/>
-          <a:lstStyle/>
-          <a:p>
-            <a:pPr algn="ctr" indent="0" marL="0">
-              <a:buNone/>
-            </a:pPr>
-            <a:r>
-              <a:rPr lang="en-US" sz="1500" b="1" dirty="0">
-                <a:solidFill>
-                  <a:srgbClr val="FFFFFF"/>
-                </a:solidFill>
-                <a:latin typeface="Calibri" pitchFamily="34" charset="0"/>
-                <a:ea typeface="Calibri" pitchFamily="34" charset="-122"/>
-                <a:cs typeface="Calibri" pitchFamily="34" charset="-120"/>
-              </a:rPr>
-              <a:t>Terugkerend</a:t>
-            </a:r>
-            <a:endParaRPr lang="en-US" sz="1500" dirty="0"/>
-          </a:p>
-        </p:txBody>
-      </p:sp>
-      <p:sp>
-        <p:nvSpPr>
-          <p:cNvPr id="13" name="Text 11"/>
-          <p:cNvSpPr/>
-          <p:nvPr/>
-        </p:nvSpPr>
-        <p:spPr>
-          <a:xfrm>
-            <a:off x="822960" y="5212080"/>
+            <a:off x="822960" y="5166360"/>
             <a:ext cx="10515600" cy="548640"/>
           </a:xfrm>
           <a:prstGeom prst="rect">
@@ -2804,7 +2707,7 @@
                 <a:ea typeface="Calibri" pitchFamily="34" charset="-122"/>
                 <a:cs typeface="Calibri" pitchFamily="34" charset="-120"/>
               </a:rPr>
-              <a:t>Eén klein stukje op je bestaande site maakt hem adaptief. Zelfde CMS, andere volgorde per bezoeker.</a:t>
+              <a:t>Eén regel code in je site maakt hem adaptief. Zelfde CMS, andere volgorde per bezoeker.</a:t>
             </a:r>
             <a:endParaRPr lang="en-US" sz="1450" dirty="0"/>
           </a:p>
@@ -3156,8 +3059,8 @@
         </p:nvSpPr>
         <p:spPr>
           <a:xfrm>
-            <a:off x="640080" y="5486400"/>
-            <a:ext cx="10881360" cy="457200"/>
+            <a:off x="640080" y="5468112"/>
+            <a:ext cx="10881360" cy="365760"/>
           </a:xfrm>
           <a:prstGeom prst="rect">
             <a:avLst/>
@@ -3173,7 +3076,7 @@
               <a:buNone/>
             </a:pPr>
             <a:r>
-              <a:rPr lang="en-US" sz="1400" b="1" i="1" dirty="0">
+              <a:rPr lang="en-US" sz="1400" b="1" dirty="0">
                 <a:solidFill>
                   <a:srgbClr val="0FA3A3"/>
                 </a:solidFill>
@@ -3181,9 +3084,48 @@
                 <a:ea typeface="Calibri" pitchFamily="34" charset="-122"/>
                 <a:cs typeface="Calibri" pitchFamily="34" charset="-120"/>
               </a:rPr>
+              <a:t>Geen profielen op persoonsniveau, en je data staat in Europa.</a:t>
+            </a:r>
+            <a:endParaRPr lang="en-US" sz="1400" dirty="0"/>
+          </a:p>
+        </p:txBody>
+      </p:sp>
+      <p:sp>
+        <p:nvSpPr>
+          <p:cNvPr id="20" name="Text 18"/>
+          <p:cNvSpPr/>
+          <p:nvPr/>
+        </p:nvSpPr>
+        <p:spPr>
+          <a:xfrm>
+            <a:off x="640080" y="5870448"/>
+            <a:ext cx="10881360" cy="457200"/>
+          </a:xfrm>
+          <a:prstGeom prst="rect">
+            <a:avLst/>
+          </a:prstGeom>
+          <a:noFill/>
+          <a:ln/>
+        </p:spPr>
+        <p:txBody>
+          <a:bodyPr wrap="square" lIns="0" tIns="0" rIns="0" bIns="0" rtlCol="0" anchor="ctr"/>
+          <a:lstStyle/>
+          <a:p>
+            <a:pPr indent="0" marL="0">
+              <a:buNone/>
+            </a:pPr>
+            <a:r>
+              <a:rPr lang="en-US" sz="1350" i="1" dirty="0">
+                <a:solidFill>
+                  <a:srgbClr val="5F7B88"/>
+                </a:solidFill>
+                <a:latin typeface="Calibri" pitchFamily="34" charset="0"/>
+                <a:ea typeface="Calibri" pitchFamily="34" charset="-122"/>
+                <a:cs typeface="Calibri" pitchFamily="34" charset="-120"/>
+              </a:rPr>
               <a:t>Dat laatste overtuigt het meest: niet dat het personaliseert, maar dat je het zélf kunt meten.</a:t>
             </a:r>
-            <a:endParaRPr lang="en-US" sz="1400" dirty="0"/>
+            <a:endParaRPr lang="en-US" sz="1350" dirty="0"/>
           </a:p>
         </p:txBody>
       </p:sp>

</xml_diff>